<commit_message>
Finalize LearnFlow deployment records and delivery assets
</commit_message>
<xml_diff>
--- a/output/slides/LearnFlow学习流动-答辩演示.pptx
+++ b/output/slides/LearnFlow学习流动-答辩演示.pptx
@@ -3581,7 +3581,7 @@
       </p:sp>
       <p:pic>
         <p:nvPicPr>
-          <p:cNvPr id="60" name="Image 0" descr="C:\Users\Asus\Documents\ChatGPT\REAL 大创\output\brand\buddy-cat.png">    </p:cNvPr>
+          <p:cNvPr id="60" name="Image 0" descr="C:\Users\Asus\Documents\ChatGPT\REAL 大创\output\brand\learnflow-logo.png">    </p:cNvPr>
           <p:cNvPicPr>
             <a:picLocks noChangeAspect="1"/>
           </p:cNvPicPr>
@@ -10117,7 +10117,7 @@
       </p:sp>
       <p:pic>
         <p:nvPicPr>
-          <p:cNvPr id="60" name="Image 0" descr="C:\Users\Asus\Documents\ChatGPT\REAL 大创\output\brand\buddy-cat.png">    </p:cNvPr>
+          <p:cNvPr id="60" name="Image 0" descr="C:\Users\Asus\Documents\ChatGPT\REAL 大创\output\brand\learnflow-logo.png">    </p:cNvPr>
           <p:cNvPicPr>
             <a:picLocks noChangeAspect="1"/>
           </p:cNvPicPr>

</xml_diff>